<commit_message>
Baseline before Salesforce->MySQL CRM migration
Snapshot of the working tree (deck/doc regeneration and Qlarity branding
work) so the CRM migration diff is readable on its own.

Co-Authored-By: Claude Opus 5 <noreply@anthropic.com>
</commit_message>
<xml_diff>
--- a/MCG_Project_Qlarity_Summary.pptx
+++ b/MCG_Project_Qlarity_Summary.pptx
@@ -18,9 +18,10 @@
     <p:sldId id="266" r:id="rId12"/>
     <p:sldId id="267" r:id="rId13"/>
     <p:sldId id="268" r:id="rId14"/>
+    <p:sldId id="269" r:id="rId15"/>
   </p:sldIdLst>
   <p:notesMasterIdLst>
-    <p:notesMasterId r:id="rId15"/>
+    <p:notesMasterId r:id="rId16"/>
   </p:notesMasterIdLst>
   <p:sldSz cx="12192000" cy="6858000"/>
   <p:notesSz cx="6858000" cy="12192000"/>
@@ -908,6 +909,94 @@
 </p:notes>
 </file>
 
+<file path=ppt/notesSlides/notesSlide14.xml><?xml version="1.0" encoding="utf-8"?>
+<p:notes xmlns:a="http://schemas.openxmlformats.org/drawingml/2006/main" xmlns:r="http://schemas.openxmlformats.org/officeDocument/2006/relationships" xmlns:p="http://schemas.openxmlformats.org/presentationml/2006/main">
+  <p:cSld>
+    <p:spTree>
+      <p:nvGrpSpPr>
+        <p:cNvPr id="1" name=""/>
+        <p:cNvGrpSpPr/>
+        <p:nvPr/>
+      </p:nvGrpSpPr>
+      <p:grpSpPr>
+        <a:xfrm>
+          <a:off x="0" y="0"/>
+          <a:ext cx="0" cy="0"/>
+          <a:chOff x="0" y="0"/>
+          <a:chExt cx="0" cy="0"/>
+        </a:xfrm>
+      </p:grpSpPr>
+      <p:sp>
+        <p:nvSpPr>
+          <p:cNvPr id="2" name="Slide Image Placeholder 1"/>
+          <p:cNvSpPr>
+            <a:spLocks noGrp="1" noRot="1" noChangeAspect="1"/>
+          </p:cNvSpPr>
+          <p:nvPr>
+            <p:ph type="sldImg"/>
+          </p:nvPr>
+        </p:nvSpPr>
+        <p:spPr/>
+      </p:sp>
+      <p:sp>
+        <p:nvSpPr>
+          <p:cNvPr id="3" name="Notes Placeholder 2"/>
+          <p:cNvSpPr>
+            <a:spLocks noGrp="1"/>
+          </p:cNvSpPr>
+          <p:nvPr>
+            <p:ph type="body" idx="1"/>
+          </p:nvPr>
+        </p:nvSpPr>
+        <p:spPr/>
+        <p:txBody>
+          <a:bodyPr/>
+          <a:lstStyle/>
+          <a:p>
+            <a:r>
+              <a:rPr lang="en-US" dirty="0"/>
+              <a:t/>
+            </a:r>
+            <a:endParaRPr lang="en-US" dirty="0"/>
+          </a:p>
+        </p:txBody>
+      </p:sp>
+      <p:sp>
+        <p:nvSpPr>
+          <p:cNvPr id="4" name="Slide Number Placeholder 3"/>
+          <p:cNvSpPr>
+            <a:spLocks noGrp="1"/>
+          </p:cNvSpPr>
+          <p:nvPr>
+            <p:ph type="sldNum" sz="quarter" idx="10"/>
+          </p:nvPr>
+        </p:nvSpPr>
+        <p:spPr/>
+        <p:txBody>
+          <a:bodyPr/>
+          <a:lstStyle/>
+          <a:p>
+            <a:fld id="{F7021451-1387-4CA6-816F-3879F97B5CBC}" type="slidenum">
+              <a:rPr lang="en-US"/>
+              <a:t>14</a:t>
+            </a:fld>
+            <a:endParaRPr lang="en-US"/>
+          </a:p>
+        </p:txBody>
+      </p:sp>
+    </p:spTree>
+    <p:extLst>
+      <p:ext uri="{BB962C8B-B14F-4D97-AF65-F5344CB8AC3E}">
+        <p14:creationId xmlns:p14="http://schemas.microsoft.com/office/powerpoint/2010/main" val="1024086991"/>
+      </p:ext>
+    </p:extLst>
+  </p:cSld>
+  <p:clrMapOvr>
+    <a:masterClrMapping/>
+  </p:clrMapOvr>
+</p:notes>
+</file>
+
 <file path=ppt/notesSlides/notesSlide2.xml><?xml version="1.0" encoding="utf-8"?>
 <p:notes xmlns:a="http://schemas.openxmlformats.org/drawingml/2006/main" xmlns:r="http://schemas.openxmlformats.org/officeDocument/2006/relationships" xmlns:p="http://schemas.openxmlformats.org/presentationml/2006/main">
   <p:cSld>
@@ -6653,6 +6742,355 @@
               <a:t>Project Qlarity repository &amp; demo guide — [placeholder]</a:t>
             </a:r>
             <a:endParaRPr lang="en-US" sz="1200" dirty="0"/>
+          </a:p>
+        </p:txBody>
+      </p:sp>
+    </p:spTree>
+  </p:cSld>
+  <p:clrMapOvr>
+    <a:masterClrMapping/>
+  </p:clrMapOvr>
+</p:sld>
+</file>
+
+<file path=ppt/slides/slide14.xml><?xml version="1.0" encoding="utf-8"?>
+<p:sld xmlns:a="http://schemas.openxmlformats.org/drawingml/2006/main" xmlns:r="http://schemas.openxmlformats.org/officeDocument/2006/relationships" xmlns:p="http://schemas.openxmlformats.org/presentationml/2006/main">
+  <p:cSld name="Slide 14">
+    <p:bg>
+      <p:bgPr>
+        <a:solidFill>
+          <a:srgbClr val="FFFFFF"/>
+        </a:solidFill>
+      </p:bgPr>
+    </p:bg>
+    <p:spTree>
+      <p:nvGrpSpPr>
+        <p:cNvPr id="1" name=""/>
+        <p:cNvGrpSpPr/>
+        <p:nvPr/>
+      </p:nvGrpSpPr>
+      <p:grpSpPr>
+        <a:xfrm>
+          <a:off x="0" y="0"/>
+          <a:ext cx="0" cy="0"/>
+          <a:chOff x="0" y="0"/>
+          <a:chExt cx="0" cy="0"/>
+        </a:xfrm>
+      </p:grpSpPr>
+      <p:sp>
+        <p:nvSpPr>
+          <p:cNvPr id="2" name="Shape 0"/>
+          <p:cNvSpPr/>
+          <p:nvPr/>
+        </p:nvSpPr>
+        <p:spPr>
+          <a:xfrm>
+            <a:off x="0" y="0"/>
+            <a:ext cx="12188952" cy="45720"/>
+          </a:xfrm>
+          <a:prstGeom prst="rect">
+            <a:avLst/>
+          </a:prstGeom>
+          <a:solidFill>
+            <a:srgbClr val="006580"/>
+          </a:solidFill>
+          <a:ln/>
+        </p:spPr>
+      </p:sp>
+      <p:sp>
+        <p:nvSpPr>
+          <p:cNvPr id="3" name="Shape 1"/>
+          <p:cNvSpPr/>
+          <p:nvPr/>
+        </p:nvSpPr>
+        <p:spPr>
+          <a:xfrm>
+            <a:off x="457200" y="6400800"/>
+            <a:ext cx="11274552" cy="9144"/>
+          </a:xfrm>
+          <a:prstGeom prst="rect">
+            <a:avLst/>
+          </a:prstGeom>
+          <a:solidFill>
+            <a:srgbClr val="A9B3B6"/>
+          </a:solidFill>
+          <a:ln/>
+        </p:spPr>
+      </p:sp>
+      <p:pic>
+        <p:nvPicPr>
+          <p:cNvPr id="4" name="Image 0" descr="C:\Claude\MCG Full Stack\generators\assets\qlik_logo.png">    </p:cNvPr>
+          <p:cNvPicPr>
+            <a:picLocks noChangeAspect="1"/>
+          </p:cNvPicPr>
+          <p:nvPr/>
+        </p:nvPicPr>
+        <p:blipFill>
+          <a:blip r:embed="rId1"/>
+          <a:stretch>
+            <a:fillRect/>
+          </a:stretch>
+        </p:blipFill>
+        <p:spPr>
+          <a:xfrm>
+            <a:off x="457200" y="6492240"/>
+            <a:ext cx="493776" cy="274320"/>
+          </a:xfrm>
+          <a:prstGeom prst="rect">
+            <a:avLst/>
+          </a:prstGeom>
+        </p:spPr>
+      </p:pic>
+      <p:sp>
+        <p:nvSpPr>
+          <p:cNvPr id="5" name="Text 2"/>
+          <p:cNvSpPr/>
+          <p:nvPr/>
+        </p:nvSpPr>
+        <p:spPr>
+          <a:xfrm>
+            <a:off x="1280160" y="6492240"/>
+            <a:ext cx="7315200" cy="274320"/>
+          </a:xfrm>
+          <a:prstGeom prst="rect">
+            <a:avLst/>
+          </a:prstGeom>
+          <a:noFill/>
+          <a:ln/>
+        </p:spPr>
+        <p:txBody>
+          <a:bodyPr wrap="square" rtlCol="0" anchor="ctr"/>
+          <a:lstStyle/>
+          <a:p>
+            <a:pPr indent="0" marL="0">
+              <a:buNone/>
+            </a:pPr>
+            <a:r>
+              <a:rPr lang="en-US" sz="800" dirty="0">
+                <a:solidFill>
+                  <a:srgbClr val="A9B3B6"/>
+                </a:solidFill>
+                <a:latin typeface="Inter" pitchFamily="34" charset="0"/>
+                <a:ea typeface="Inter" pitchFamily="34" charset="-122"/>
+                <a:cs typeface="Inter" pitchFamily="34" charset="-120"/>
+              </a:rPr>
+              <a:t>Project Qlarity  •  MCG Demo  •  Qlik Cloud</a:t>
+            </a:r>
+            <a:endParaRPr lang="en-US" sz="800" dirty="0"/>
+          </a:p>
+        </p:txBody>
+      </p:sp>
+      <p:sp>
+        <p:nvSpPr>
+          <p:cNvPr id="6" name="Text 3"/>
+          <p:cNvSpPr/>
+          <p:nvPr/>
+        </p:nvSpPr>
+        <p:spPr>
+          <a:xfrm>
+            <a:off x="10972800" y="6492240"/>
+            <a:ext cx="914400" cy="274320"/>
+          </a:xfrm>
+          <a:prstGeom prst="rect">
+            <a:avLst/>
+          </a:prstGeom>
+          <a:noFill/>
+          <a:ln/>
+        </p:spPr>
+        <p:txBody>
+          <a:bodyPr wrap="square" rtlCol="0" anchor="ctr"/>
+          <a:lstStyle/>
+          <a:p>
+            <a:pPr algn="r" indent="0" marL="0">
+              <a:buNone/>
+            </a:pPr>
+            <a:r>
+              <a:rPr lang="en-US" sz="800" dirty="0">
+                <a:solidFill>
+                  <a:srgbClr val="A9B3B6"/>
+                </a:solidFill>
+                <a:latin typeface="Inter" pitchFamily="34" charset="0"/>
+                <a:ea typeface="Inter" pitchFamily="34" charset="-122"/>
+                <a:cs typeface="Inter" pitchFamily="34" charset="-120"/>
+              </a:rPr>
+              <a:t>14</a:t>
+            </a:r>
+            <a:endParaRPr lang="en-US" sz="800" dirty="0"/>
+          </a:p>
+        </p:txBody>
+      </p:sp>
+      <p:sp>
+        <p:nvSpPr>
+          <p:cNvPr id="7" name="Text 4"/>
+          <p:cNvSpPr/>
+          <p:nvPr/>
+        </p:nvSpPr>
+        <p:spPr>
+          <a:xfrm>
+            <a:off x="457200" y="182880"/>
+            <a:ext cx="8412480" cy="594360"/>
+          </a:xfrm>
+          <a:prstGeom prst="rect">
+            <a:avLst/>
+          </a:prstGeom>
+          <a:noFill/>
+          <a:ln/>
+        </p:spPr>
+        <p:txBody>
+          <a:bodyPr wrap="square" rtlCol="0" anchor="ctr"/>
+          <a:lstStyle/>
+          <a:p>
+            <a:pPr indent="0" marL="0">
+              <a:buNone/>
+            </a:pPr>
+            <a:r>
+              <a:rPr lang="en-US" sz="2600" b="1" dirty="0">
+                <a:solidFill>
+                  <a:srgbClr val="19416C"/>
+                </a:solidFill>
+                <a:latin typeface="Inter" pitchFamily="34" charset="0"/>
+                <a:ea typeface="Inter" pitchFamily="34" charset="-122"/>
+                <a:cs typeface="Inter" pitchFamily="34" charset="-120"/>
+              </a:rPr>
+              <a:t>Deploy Console</a:t>
+            </a:r>
+            <a:endParaRPr lang="en-US" sz="2600" dirty="0"/>
+          </a:p>
+        </p:txBody>
+      </p:sp>
+      <p:sp>
+        <p:nvSpPr>
+          <p:cNvPr id="8" name="Text 5"/>
+          <p:cNvSpPr/>
+          <p:nvPr/>
+        </p:nvSpPr>
+        <p:spPr>
+          <a:xfrm>
+            <a:off x="548640" y="749808"/>
+            <a:ext cx="11064240" cy="292608"/>
+          </a:xfrm>
+          <a:prstGeom prst="rect">
+            <a:avLst/>
+          </a:prstGeom>
+          <a:noFill/>
+          <a:ln/>
+        </p:spPr>
+        <p:txBody>
+          <a:bodyPr wrap="square" rtlCol="0" anchor="ctr"/>
+          <a:lstStyle/>
+          <a:p>
+            <a:pPr indent="0" marL="0">
+              <a:buNone/>
+            </a:pPr>
+            <a:r>
+              <a:rPr lang="en-US" sz="1100" dirty="0">
+                <a:solidFill>
+                  <a:srgbClr val="454659"/>
+                </a:solidFill>
+                <a:latin typeface="Inter" pitchFamily="34" charset="0"/>
+                <a:ea typeface="Inter" pitchFamily="34" charset="-122"/>
+                <a:cs typeface="Inter" pitchFamily="34" charset="-120"/>
+              </a:rPr>
+              <a:t>The whole environment deploys from one repository.</a:t>
+            </a:r>
+            <a:endParaRPr lang="en-US" sz="1100" dirty="0"/>
+          </a:p>
+        </p:txBody>
+      </p:sp>
+      <p:sp>
+        <p:nvSpPr>
+          <p:cNvPr id="9" name="Shape 6"/>
+          <p:cNvSpPr/>
+          <p:nvPr/>
+        </p:nvSpPr>
+        <p:spPr>
+          <a:xfrm>
+            <a:off x="1344168" y="1133856"/>
+            <a:ext cx="7754112" cy="4901184"/>
+          </a:xfrm>
+          <a:prstGeom prst="roundRect">
+            <a:avLst>
+              <a:gd name="adj" fmla="val 746"/>
+            </a:avLst>
+          </a:prstGeom>
+          <a:solidFill>
+            <a:srgbClr val="FFFFFF"/>
+          </a:solidFill>
+          <a:ln w="12700">
+            <a:solidFill>
+              <a:srgbClr val="A9B3B6"/>
+            </a:solidFill>
+            <a:prstDash val="solid"/>
+          </a:ln>
+          <a:effectLst>
+            <a:outerShdw sx="100000" sy="100000" kx="0" ky="0" algn="bl" rotWithShape="0" blurRad="76200" dist="25400" dir="16200000">
+              <a:srgbClr val="000000">
+                <a:alpha val="18000"/>
+              </a:srgbClr>
+            </a:outerShdw>
+          </a:effectLst>
+        </p:spPr>
+      </p:sp>
+      <p:pic>
+        <p:nvPicPr>
+          <p:cNvPr id="10" name="Image 1" descr="C:\Claude\MCG Full Stack\generators\assets\screenshots\deploy-ui-wizard.png">    </p:cNvPr>
+          <p:cNvPicPr>
+            <a:picLocks noChangeAspect="1"/>
+          </p:cNvPicPr>
+          <p:nvPr/>
+        </p:nvPicPr>
+        <p:blipFill>
+          <a:blip r:embed="rId2"/>
+          <a:stretch>
+            <a:fillRect/>
+          </a:stretch>
+        </p:blipFill>
+        <p:spPr>
+          <a:xfrm>
+            <a:off x="1417320" y="1207008"/>
+            <a:ext cx="7607808" cy="4754880"/>
+          </a:xfrm>
+          <a:prstGeom prst="rect">
+            <a:avLst/>
+          </a:prstGeom>
+        </p:spPr>
+      </p:pic>
+      <p:sp>
+        <p:nvSpPr>
+          <p:cNvPr id="11" name="Text 7"/>
+          <p:cNvSpPr/>
+          <p:nvPr/>
+        </p:nvSpPr>
+        <p:spPr>
+          <a:xfrm>
+            <a:off x="1344168" y="6089904"/>
+            <a:ext cx="7754112" cy="274320"/>
+          </a:xfrm>
+          <a:prstGeom prst="rect">
+            <a:avLst/>
+          </a:prstGeom>
+          <a:noFill/>
+          <a:ln/>
+        </p:spPr>
+        <p:txBody>
+          <a:bodyPr wrap="square" rtlCol="0" anchor="t"/>
+          <a:lstStyle/>
+          <a:p>
+            <a:pPr algn="ctr" indent="0" marL="0">
+              <a:buNone/>
+            </a:pPr>
+            <a:r>
+              <a:rPr lang="en-US" sz="1000" i="1" dirty="0">
+                <a:solidFill>
+                  <a:srgbClr val="6B7280"/>
+                </a:solidFill>
+                <a:latin typeface="Inter" pitchFamily="34" charset="0"/>
+                <a:ea typeface="Inter" pitchFamily="34" charset="-122"/>
+                <a:cs typeface="Inter" pitchFamily="34" charset="-120"/>
+              </a:rPr>
+              <a:t>The MCG deploy console — 11 setup steps, Stewardship at step 11</a:t>
+            </a:r>
+            <a:endParaRPr lang="en-US" sz="1000" dirty="0"/>
           </a:p>
         </p:txBody>
       </p:sp>

</xml_diff>